<commit_message>
style: overhaul UI aesthetics and add dedicated vector logo branding for Level 6 review requirement
- Created custom vector brand logo (logo.svg, logo-icon.svg, Logo.jsx component)
- Upgraded Navbar with brand logo, Soroban testnet status badge, and quick explorer links
- Enhanced Landing page with animated hero badge, protocol stats bar (TVL, APY, Speed), 3-step guide, and feature highlights
- Upgraded Dashboard with portfolio health gauge, market table, and real-time oracle price display
- Added quick percentage selector chips (25%, 50%, 75%, MAX) in AssetModal
- Updated app metadata and SVG favicons in layout.js
</commit_message>
<xml_diff>
--- a/StellarLend_Pitch_Deck.pptx
+++ b/StellarLend_Pitch_Deck.pptx
@@ -2181,7 +2181,15 @@
                   <a:srgbClr val="9CA3AF"/>
                 </a:solidFill>
               </a:rPr>
-              <a:t>github.com/ashishh-tech/Stellar-Peer-to-Peer-Lending</a:t>
+              <a:t>github.com/ashishh-tech</a:t>
+            </a:r>
+            <a:r>
+              <a:rPr lang="en-US" sz="1200">
+                <a:solidFill>
+                  <a:srgbClr val="9CA3AF"/>
+                </a:solidFill>
+              </a:rPr>
+              <a:t>/STELLARLEND</a:t>
             </a:r>
             <a:endParaRPr lang="en-US" sz="1200" dirty="0"/>
           </a:p>

</xml_diff>